<commit_message>
VLLA 2026: real Google Form QR code and link on the last two slides
Co-Authored-By: Claude Opus 5.5 <noreply@anthropic.com>
Claude-Session: https://claude.ai/code/session_01L5t2fWvgteFsVvQKqGnV28
</commit_message>
<xml_diff>
--- a/presentations/2026-vlla/deck/zest-vlla-2026.pptx
+++ b/presentations/2026-vlla/deck/zest-vlla-2026.pptx
@@ -1903,7 +1903,7 @@
           <a:p/>
           <a:p>
             <a:r>
-              <a:t>[FORM URL PLACEHOLDER: replace the QR box with the real QR code.]</a:t>
+              <a:t>(The QR code and forms.gle/1BDJ6hXbWxbZRopP8 both go to the Get the Zest Code form. Responses land in the Get the Zest Code (Responses) sheet in your Drive.)</a:t>
             </a:r>
           </a:p>
         </p:txBody>
@@ -33621,65 +33621,72 @@
           </a:p>
         </p:txBody>
       </p:sp>
+      <p:pic>
+        <p:nvPicPr>
+          <p:cNvPr id="319" name="Picture 318" descr="form-qr.png"/>
+          <p:cNvPicPr>
+            <a:picLocks noChangeAspect="1"/>
+          </p:cNvPicPr>
+          <p:nvPr/>
+        </p:nvPicPr>
+        <p:blipFill>
+          <a:blip r:embed="rId2"/>
+          <a:stretch>
+            <a:fillRect/>
+          </a:stretch>
+        </p:blipFill>
+        <p:spPr>
+          <a:xfrm>
+            <a:off x="864107" y="868679"/>
+            <a:ext cx="3108960" cy="3108960"/>
+          </a:xfrm>
+          <a:prstGeom prst="rect">
+            <a:avLst/>
+          </a:prstGeom>
+        </p:spPr>
+      </p:pic>
       <p:sp>
         <p:nvSpPr>
-          <p:cNvPr id="319" name="Rounded Rectangle 318"/>
-          <p:cNvSpPr/>
+          <p:cNvPr id="320" name="TextBox 319"/>
+          <p:cNvSpPr txBox="1"/>
           <p:nvPr/>
         </p:nvSpPr>
         <p:spPr>
           <a:xfrm>
-            <a:off x="960120" y="1097280"/>
-            <a:ext cx="2926080" cy="2926080"/>
-          </a:xfrm>
-          <a:prstGeom prst="roundRect">
+            <a:off x="512064" y="4069080"/>
+            <a:ext cx="3813048" cy="365760"/>
+          </a:xfrm>
+          <a:prstGeom prst="rect">
             <a:avLst/>
           </a:prstGeom>
-          <a:solidFill>
-            <a:srgbClr val="FFFFFF"/>
-          </a:solidFill>
-          <a:ln w="19050">
-            <a:solidFill>
-              <a:srgbClr val="960000"/>
-            </a:solidFill>
-          </a:ln>
-          <a:effectLst/>
+          <a:noFill/>
         </p:spPr>
-        <p:style>
-          <a:lnRef idx="1">
-            <a:schemeClr val="accent1"/>
-          </a:lnRef>
-          <a:fillRef idx="3">
-            <a:schemeClr val="accent1"/>
-          </a:fillRef>
-          <a:effectRef idx="2">
-            <a:schemeClr val="accent1"/>
-          </a:effectRef>
-          <a:fontRef idx="minor">
-            <a:schemeClr val="lt1"/>
-          </a:fontRef>
-        </p:style>
         <p:txBody>
-          <a:bodyPr rtlCol="0" anchor="ctr" wrap="square"/>
+          <a:bodyPr wrap="square" anchor="t" lIns="0" rIns="0" tIns="0" bIns="0">
+            <a:spAutoFit/>
+          </a:bodyPr>
           <a:lstStyle/>
           <a:p>
-            <a:pPr algn="ctr"/>
+            <a:pPr algn="ctr">
+              <a:spcAft>
+                <a:spcPts val="600"/>
+              </a:spcAft>
+            </a:pPr>
             <a:r>
-              <a:rPr sz="1100" b="1">
+              <a:rPr sz="1200" b="1" i="0">
                 <a:solidFill>
-                  <a:srgbClr val="960000"/>
+                  <a:srgbClr val="1B3168"/>
                 </a:solidFill>
                 <a:latin typeface="Roboto"/>
               </a:rPr>
-              <a:t>QR code for the Google Form
-[FORM URL PLACEHOLDER]</a:t>
+              <a:t>forms.gle/1BDJ6hXbWxbZRopP8</a:t>
             </a:r>
           </a:p>
         </p:txBody>
       </p:sp>
       <p:sp>
         <p:nvSpPr>
-          <p:cNvPr id="320" name="TextBox 319"/>
+          <p:cNvPr id="321" name="TextBox 320"/>
           <p:cNvSpPr txBox="1"/>
           <p:nvPr/>
         </p:nvSpPr>
@@ -33718,7 +33725,7 @@
       </p:sp>
       <p:sp>
         <p:nvSpPr>
-          <p:cNvPr id="321" name="TextBox 320"/>
+          <p:cNvPr id="322" name="TextBox 321"/>
           <p:cNvSpPr txBox="1"/>
           <p:nvPr/>
         </p:nvSpPr>
@@ -33766,7 +33773,7 @@
                 </a:solidFill>
                 <a:latin typeface="Roboto"/>
               </a:rPr>
-              <a:t>[short link]</a:t>
+              <a:t>forms.gle/1BDJ6hXbWxbZRopP8</a:t>
             </a:r>
           </a:p>
           <a:p>
@@ -33821,7 +33828,7 @@
       </p:sp>
       <p:sp>
         <p:nvSpPr>
-          <p:cNvPr id="322" name="TextBox 321"/>
+          <p:cNvPr id="323" name="TextBox 322"/>
           <p:cNvSpPr txBox="1"/>
           <p:nvPr/>
         </p:nvSpPr>
@@ -34208,65 +34215,72 @@
           </a:ln>
         </p:spPr>
       </p:pic>
+      <p:pic>
+        <p:nvPicPr>
+          <p:cNvPr id="206" name="Picture 205" descr="form-qr.png"/>
+          <p:cNvPicPr>
+            <a:picLocks noChangeAspect="1"/>
+          </p:cNvPicPr>
+          <p:nvPr/>
+        </p:nvPicPr>
+        <p:blipFill>
+          <a:blip r:embed="rId2"/>
+          <a:stretch>
+            <a:fillRect/>
+          </a:stretch>
+        </p:blipFill>
+        <p:spPr>
+          <a:xfrm>
+            <a:off x="1211579" y="868679"/>
+            <a:ext cx="3108960" cy="3108960"/>
+          </a:xfrm>
+          <a:prstGeom prst="rect">
+            <a:avLst/>
+          </a:prstGeom>
+        </p:spPr>
+      </p:pic>
       <p:sp>
         <p:nvSpPr>
-          <p:cNvPr id="206" name="Rounded Rectangle 205"/>
-          <p:cNvSpPr/>
+          <p:cNvPr id="207" name="TextBox 206"/>
+          <p:cNvSpPr txBox="1"/>
           <p:nvPr/>
         </p:nvSpPr>
         <p:spPr>
           <a:xfrm>
-            <a:off x="1280160" y="1097280"/>
-            <a:ext cx="2926080" cy="2926080"/>
-          </a:xfrm>
-          <a:prstGeom prst="roundRect">
+            <a:off x="530352" y="4069080"/>
+            <a:ext cx="4471416" cy="365760"/>
+          </a:xfrm>
+          <a:prstGeom prst="rect">
             <a:avLst/>
           </a:prstGeom>
-          <a:solidFill>
-            <a:srgbClr val="FFFFFF"/>
-          </a:solidFill>
-          <a:ln w="19050">
-            <a:solidFill>
-              <a:srgbClr val="960000"/>
-            </a:solidFill>
-          </a:ln>
-          <a:effectLst/>
+          <a:noFill/>
         </p:spPr>
-        <p:style>
-          <a:lnRef idx="1">
-            <a:schemeClr val="accent1"/>
-          </a:lnRef>
-          <a:fillRef idx="3">
-            <a:schemeClr val="accent1"/>
-          </a:fillRef>
-          <a:effectRef idx="2">
-            <a:schemeClr val="accent1"/>
-          </a:effectRef>
-          <a:fontRef idx="minor">
-            <a:schemeClr val="lt1"/>
-          </a:fontRef>
-        </p:style>
         <p:txBody>
-          <a:bodyPr rtlCol="0" anchor="ctr" wrap="square"/>
+          <a:bodyPr wrap="square" anchor="t" lIns="0" rIns="0" tIns="0" bIns="0">
+            <a:spAutoFit/>
+          </a:bodyPr>
           <a:lstStyle/>
           <a:p>
-            <a:pPr algn="ctr"/>
+            <a:pPr algn="ctr">
+              <a:spcAft>
+                <a:spcPts val="600"/>
+              </a:spcAft>
+            </a:pPr>
             <a:r>
-              <a:rPr sz="1100" b="1">
+              <a:rPr sz="1200" b="1" i="0">
                 <a:solidFill>
-                  <a:srgbClr val="960000"/>
+                  <a:srgbClr val="1B3168"/>
                 </a:solidFill>
                 <a:latin typeface="Roboto"/>
               </a:rPr>
-              <a:t>Same QR code
-[FORM URL PLACEHOLDER]</a:t>
+              <a:t>Get the code: forms.gle/1BDJ6hXbWxbZRopP8</a:t>
             </a:r>
           </a:p>
         </p:txBody>
       </p:sp>
       <p:sp>
         <p:nvSpPr>
-          <p:cNvPr id="207" name="TextBox 206"/>
+          <p:cNvPr id="208" name="TextBox 207"/>
           <p:cNvSpPr txBox="1"/>
           <p:nvPr/>
         </p:nvSpPr>
@@ -34305,7 +34319,7 @@
       </p:sp>
       <p:sp>
         <p:nvSpPr>
-          <p:cNvPr id="208" name="TextBox 207"/>
+          <p:cNvPr id="209" name="TextBox 208"/>
           <p:cNvSpPr txBox="1"/>
           <p:nvPr/>
         </p:nvSpPr>

</xml_diff>

<commit_message>
VLLA 2026: Start over in Launch Lab, graph sets in Graph Match
- Launch Lab 1.1.0: two-tap Start over inside Canvas, behind a new
  allowRestart setting (on by default for the demo)
- Graph Match 1.1.0: a Which graphs setting in the embed form (Editor's
  list, Mixed, Quadratics, Absolute value, Square roots, Cubics, Sine
  waves, Lines), and the same choice in the phone preview banner
- Deck: grading type on the gallery overview tiles; notes updated

Co-Authored-By: Claude Opus 5.5 <noreply@anthropic.com>
Claude-Session: https://claude.ai/code/session_01L5t2fWvgteFsVvQKqGnV28
</commit_message>
<xml_diff>
--- a/presentations/2026-vlla/deck/zest-vlla-2026.pptx
+++ b/presentations/2026-vlla/deck/zest-vlla-2026.pptx
@@ -996,7 +996,7 @@
           <a:p/>
           <a:p>
             <a:r>
-              <a:t>So what else can you make? Every one of these came from a prompt, the same way you saw in the recording. They're on my sandbox. The next four slides have QR codes, so try them on your phone while I talk. On a phone they open in a preview mode, so nothing gets saved.</a:t>
+              <a:t>So what else can you make? Three of these are auto-graded and one, Sketch &amp; Label, is teacher-graded. Every one of these came from a prompt, the same way you saw in the recording. They're on my sandbox. The next four slides have QR codes, so try them on your phone while I talk. On a phone they open in a preview mode, so nothing gets saved.</a:t>
             </a:r>
           </a:p>
         </p:txBody>
@@ -1072,7 +1072,7 @@
           <a:p/>
           <a:p>
             <a:r>
-              <a:t>Students lock in a predicted angle, then take one scored launch. After that they can take practice shots. A lot of them discover that two different angles hit the same target, which is a nice conversation starter.</a:t>
+              <a:t>Students lock in a predicted angle, then take one scored launch. (For today there's a Start over button, which the teacher can turn off for a real graded check.) After that they can take practice shots. A lot of them discover that two different angles hit the same target, which is a nice conversation starter.</a:t>
             </a:r>
           </a:p>
           <a:p/>
@@ -1154,7 +1154,7 @@
           <a:p/>
           <a:p>
             <a:r>
-              <a:t>The part I want you to notice: the teacher picks the target functions on a settings page. The AI built that settings page too, from "I want to pick the target functions myself." One package, set up differently for each class.</a:t>
+              <a:t>The part I want you to notice: when the teacher embeds it, they pick a set of graphs (quadratics, absolute value, sine waves and so on), or open the settings editor and build their own list. The AI built that settings page too, from "I want to pick the target functions myself." One package, set up differently for each class. On your phone, the preview has the same choice at the top.</a:t>
             </a:r>
           </a:p>
           <a:p/>
@@ -24728,7 +24728,7 @@
           <a:p>
             <a:pPr algn="l">
               <a:spcAft>
-                <a:spcPts val="600"/>
+                <a:spcPts val="400"/>
               </a:spcAft>
             </a:pPr>
             <a:r>
@@ -24739,6 +24739,22 @@
                 <a:latin typeface="Roboto"/>
               </a:rPr>
               <a:t>Physics</a:t>
+            </a:r>
+          </a:p>
+          <a:p>
+            <a:pPr algn="l">
+              <a:spcAft>
+                <a:spcPts val="600"/>
+              </a:spcAft>
+            </a:pPr>
+            <a:r>
+              <a:rPr sz="1000" b="1" i="0">
+                <a:solidFill>
+                  <a:srgbClr val="1B3168"/>
+                </a:solidFill>
+                <a:latin typeface="Roboto"/>
+              </a:rPr>
+              <a:t>Auto-graded</a:t>
             </a:r>
           </a:p>
         </p:txBody>
@@ -24807,7 +24823,7 @@
           <a:p>
             <a:pPr algn="l">
               <a:spcAft>
-                <a:spcPts val="600"/>
+                <a:spcPts val="400"/>
               </a:spcAft>
             </a:pPr>
             <a:r>
@@ -24818,6 +24834,22 @@
                 <a:latin typeface="Roboto"/>
               </a:rPr>
               <a:t>Algebra 2</a:t>
+            </a:r>
+          </a:p>
+          <a:p>
+            <a:pPr algn="l">
+              <a:spcAft>
+                <a:spcPts val="600"/>
+              </a:spcAft>
+            </a:pPr>
+            <a:r>
+              <a:rPr sz="1000" b="1" i="0">
+                <a:solidFill>
+                  <a:srgbClr val="1B3168"/>
+                </a:solidFill>
+                <a:latin typeface="Roboto"/>
+              </a:rPr>
+              <a:t>Auto-graded</a:t>
             </a:r>
           </a:p>
         </p:txBody>
@@ -24886,7 +24918,7 @@
           <a:p>
             <a:pPr algn="l">
               <a:spcAft>
-                <a:spcPts val="600"/>
+                <a:spcPts val="400"/>
               </a:spcAft>
             </a:pPr>
             <a:r>
@@ -24897,6 +24929,22 @@
                 <a:latin typeface="Roboto"/>
               </a:rPr>
               <a:t>Life Science</a:t>
+            </a:r>
+          </a:p>
+          <a:p>
+            <a:pPr algn="l">
+              <a:spcAft>
+                <a:spcPts val="600"/>
+              </a:spcAft>
+            </a:pPr>
+            <a:r>
+              <a:rPr sz="1000" b="1" i="0">
+                <a:solidFill>
+                  <a:srgbClr val="960000"/>
+                </a:solidFill>
+                <a:latin typeface="Roboto"/>
+              </a:rPr>
+              <a:t>Teacher-graded</a:t>
             </a:r>
           </a:p>
         </p:txBody>
@@ -24965,7 +25013,7 @@
           <a:p>
             <a:pPr algn="l">
               <a:spcAft>
-                <a:spcPts val="600"/>
+                <a:spcPts val="400"/>
               </a:spcAft>
             </a:pPr>
             <a:r>
@@ -24976,6 +25024,22 @@
                 <a:latin typeface="Roboto"/>
               </a:rPr>
               <a:t>U.S. History</a:t>
+            </a:r>
+          </a:p>
+          <a:p>
+            <a:pPr algn="l">
+              <a:spcAft>
+                <a:spcPts val="600"/>
+              </a:spcAft>
+            </a:pPr>
+            <a:r>
+              <a:rPr sz="1000" b="1" i="0">
+                <a:solidFill>
+                  <a:srgbClr val="1B3168"/>
+                </a:solidFill>
+                <a:latin typeface="Roboto"/>
+              </a:rPr>
+              <a:t>Auto-graded</a:t>
             </a:r>
           </a:p>
         </p:txBody>
@@ -26309,7 +26373,7 @@
                 </a:solidFill>
                 <a:latin typeface="Roboto"/>
               </a:rPr>
-              <a:t>The AI also built the settings page where the teacher picks the targets.</a:t>
+              <a:t>Teachers pick a ready-made set of graphs, or build their own in a settings page the AI also built.</a:t>
             </a:r>
           </a:p>
         </p:txBody>

</xml_diff>

<commit_message>
VLLA 2026: reorder the deck
- What Zest Solves (was So What's the Catch?) right after the opening
  question
- One Sentence and Let's Watch moved after the four zest examples
- Why Build It Ourselves? cut; photo placeholder removed from About Me
- Notes, clocks and outline updated (talk ends at 24:10)

Co-Authored-By: Claude Opus 5.5 <noreply@anthropic.com>
Claude-Session: https://claude.ai/code/session_01L5t2fWvgteFsVvQKqGnV28
</commit_message>
<xml_diff>
--- a/presentations/2026-vlla/deck/zest-vlla-2026.pptx
+++ b/presentations/2026-vlla/deck/zest-vlla-2026.pptx
@@ -13,8 +13,6 @@
     <p:sldId id="283" r:id="rId35"/>
     <p:sldId id="284" r:id="rId36"/>
     <p:sldId id="285" r:id="rId37"/>
-    <p:sldId id="286" r:id="rId38"/>
-    <p:sldId id="287" r:id="rId39"/>
     <p:sldId id="288" r:id="rId40"/>
     <p:sldId id="289" r:id="rId41"/>
     <p:sldId id="290" r:id="rId42"/>
@@ -26,7 +24,8 @@
     <p:sldId id="296" r:id="rId48"/>
     <p:sldId id="297" r:id="rId49"/>
     <p:sldId id="298" r:id="rId50"/>
-    <p:sldId id="299" r:id="rId51"/>
+    <p:sldId id="286" r:id="rId38"/>
+    <p:sldId id="287" r:id="rId39"/>
     <p:sldId id="300" r:id="rId52"/>
     <p:sldId id="301" r:id="rId53"/>
     <p:sldId id="302" r:id="rId54"/>
@@ -819,7 +818,7 @@
           <a:lstStyle/>
           <a:p>
             <a:r>
-              <a:t>TIME: 1:00 (clock 13:30)</a:t>
+              <a:t>TIME: 1:00 (clock 10:00)</a:t>
             </a:r>
           </a:p>
           <a:p/>
@@ -916,7 +915,7 @@
           <a:lstStyle/>
           <a:p>
             <a:r>
-              <a:t>TIME: 1:00 (clock 14:30)</a:t>
+              <a:t>TIME: 1:00 (clock 11:00)</a:t>
             </a:r>
           </a:p>
           <a:p/>
@@ -990,13 +989,13 @@
           <a:lstStyle/>
           <a:p>
             <a:r>
-              <a:t>TIME: 0:20 (clock 14:50)</a:t>
+              <a:t>TIME: 0:20 (clock 11:20)</a:t>
             </a:r>
           </a:p>
           <a:p/>
           <a:p>
             <a:r>
-              <a:t>So what else can you make? Three of these are auto-graded and one, Sketch &amp; Label, is teacher-graded. Every one of these came from a prompt, the same way you saw in the recording. They're on my sandbox. The next four slides have QR codes, so try them on your phone while I talk. On a phone they open in a preview mode, so nothing gets saved.</a:t>
+              <a:t>So what else can you make? Three of these are auto-graded and one, Sketch &amp; Label, is teacher-graded. Every one of these came from a prompt. I'll show you how in a few minutes. They're on my sandbox. The next four slides have QR codes, so try them on your phone while I talk. On a phone they open in a preview mode, so nothing gets saved.</a:t>
             </a:r>
           </a:p>
         </p:txBody>
@@ -1054,7 +1053,7 @@
           <a:lstStyle/>
           <a:p>
             <a:r>
-              <a:t>TIME: 1:05 (clock 15:55)</a:t>
+              <a:t>TIME: 1:05 (clock 12:25)</a:t>
             </a:r>
           </a:p>
           <a:p/>
@@ -1066,7 +1065,7 @@
           <a:p/>
           <a:p>
             <a:r>
-              <a:t>Same sentence as the recording. This time I answered a few follow-up questions: five rounds, practice shots after each scored one, and settings for the targets, launch speed and how close counts as a hit. That's the difference between this one and the one you saw built.</a:t>
+              <a:t>This came from the sentence on the slide plus a few answers to follow-up questions: five rounds, practice shots after each scored one, and settings for the targets, launch speed and how close counts as a hit. In a few minutes you'll see what that sentence alone produces.</a:t>
             </a:r>
           </a:p>
           <a:p/>
@@ -1136,7 +1135,7 @@
           <a:lstStyle/>
           <a:p>
             <a:r>
-              <a:t>TIME: 1:05 (clock 17:00)</a:t>
+              <a:t>TIME: 1:05 (clock 13:30)</a:t>
             </a:r>
           </a:p>
           <a:p/>
@@ -1218,7 +1217,7 @@
           <a:lstStyle/>
           <a:p>
             <a:r>
-              <a:t>TIME: 1:05 (clock 18:05)</a:t>
+              <a:t>TIME: 1:05 (clock 14:35)</a:t>
             </a:r>
           </a:p>
           <a:p/>
@@ -1300,7 +1299,7 @@
           <a:lstStyle/>
           <a:p>
             <a:r>
-              <a:t>TIME: 1:05 (clock 19:10)</a:t>
+              <a:t>TIME: 1:05 (clock 15:40)</a:t>
             </a:r>
           </a:p>
           <a:p/>
@@ -1325,97 +1324,6 @@
           <a:p>
             <a:r>
               <a:t>[CLICK] SpeedGrader shows a timeline of every wrong try and hint, so you can see where a student got stuck.</a:t>
-            </a:r>
-          </a:p>
-        </p:txBody>
-      </p:sp>
-    </p:spTree>
-  </p:cSld>
-  <p:clrMapOvr>
-    <a:masterClrMapping/>
-  </p:clrMapOvr>
-</p:notes>
-</file>
-
-<file path=ppt/notesSlides/notesSlide17.xml><?xml version="1.0" encoding="utf-8"?>
-<p:notes xmlns:a="http://schemas.openxmlformats.org/drawingml/2006/main" xmlns:p="http://schemas.openxmlformats.org/presentationml/2006/main" xmlns:r="http://schemas.openxmlformats.org/officeDocument/2006/relationships">
-  <p:cSld>
-    <p:spTree>
-      <p:nvGrpSpPr>
-        <p:cNvPr id="1" name=""/>
-        <p:cNvGrpSpPr/>
-        <p:nvPr/>
-      </p:nvGrpSpPr>
-      <p:grpSpPr>
-        <a:xfrm>
-          <a:off x="0" y="0"/>
-          <a:ext cx="0" cy="0"/>
-          <a:chOff x="0" y="0"/>
-          <a:chExt cx="0" cy="0"/>
-        </a:xfrm>
-      </p:grpSpPr>
-      <p:sp>
-        <p:nvSpPr>
-          <p:cNvPr id="2" name="Slide Image Placeholder 1"/>
-          <p:cNvSpPr>
-            <a:spLocks noGrp="1"/>
-          </p:cNvSpPr>
-          <p:nvPr>
-            <p:ph type="sldImg" idx="2"/>
-          </p:nvPr>
-        </p:nvSpPr>
-        <p:spPr/>
-      </p:sp>
-      <p:sp>
-        <p:nvSpPr>
-          <p:cNvPr id="3" name="Notes Placeholder 2"/>
-          <p:cNvSpPr>
-            <a:spLocks noGrp="1"/>
-          </p:cNvSpPr>
-          <p:nvPr>
-            <p:ph type="body" idx="1"/>
-          </p:nvPr>
-        </p:nvSpPr>
-        <p:spPr/>
-        <p:txBody>
-          <a:bodyPr/>
-          <a:lstStyle/>
-          <a:p>
-            <a:r>
-              <a:t>TIME: 0:45 (clock 19:55)</a:t>
-            </a:r>
-          </a:p>
-          <a:p/>
-          <a:p>
-            <a:r>
-              <a:t>Why build it ourselves instead of buying something?</a:t>
-            </a:r>
-          </a:p>
-          <a:p/>
-          <a:p>
-            <a:r>
-              <a:t>[CLICK] We needed the grades and the student's work inside Canvas, not in another tool.</a:t>
-            </a:r>
-          </a:p>
-          <a:p>
-            <a:r>
-              <a:t>[CLICK] Student data stays on our server.</a:t>
-            </a:r>
-          </a:p>
-          <a:p>
-            <a:r>
-              <a:t>[CLICK] No per-seat license.</a:t>
-            </a:r>
-          </a:p>
-          <a:p>
-            <a:r>
-              <a:t>[CLICK] We already had content that needed a home.</a:t>
-            </a:r>
-          </a:p>
-          <a:p/>
-          <a:p>
-            <a:r>
-              <a:t>[Kyle: replace with your real reasons.]</a:t>
             </a:r>
           </a:p>
         </p:txBody>
@@ -1473,7 +1381,7 @@
           <a:lstStyle/>
           <a:p>
             <a:r>
-              <a:t>TIME: 1:30 (clock 21:25)</a:t>
+              <a:t>TIME: 1:30 (clock 20:40)</a:t>
             </a:r>
           </a:p>
           <a:p/>
@@ -1561,7 +1469,7 @@
           <a:lstStyle/>
           <a:p>
             <a:r>
-              <a:t>TIME: 0:45 (clock 22:10)</a:t>
+              <a:t>TIME: 0:45 (clock 21:25)</a:t>
             </a:r>
           </a:p>
           <a:p/>
@@ -1658,7 +1566,7 @@
           <a:p/>
           <a:p>
             <a:r>
-              <a:t>[Kyle: add a photo in the circle, and update anything that's changed.]</a:t>
+              <a:t>[Kyle: update anything that's changed.]</a:t>
             </a:r>
           </a:p>
         </p:txBody>
@@ -1716,7 +1624,7 @@
           <a:lstStyle/>
           <a:p>
             <a:r>
-              <a:t>TIME: 1:15 (clock 23:25)</a:t>
+              <a:t>TIME: 1:15 (clock 22:40)</a:t>
             </a:r>
           </a:p>
           <a:p/>
@@ -1801,7 +1709,7 @@
           <a:lstStyle/>
           <a:p>
             <a:r>
-              <a:t>TIME: 0:45 (clock 24:10)</a:t>
+              <a:t>TIME: 0:45 (clock 23:25)</a:t>
             </a:r>
           </a:p>
           <a:p/>
@@ -1885,7 +1793,7 @@
           <a:lstStyle/>
           <a:p>
             <a:r>
-              <a:t>TIME: 0:45 (clock 24:55)</a:t>
+              <a:t>TIME: 0:45 (clock 24:10)</a:t>
             </a:r>
           </a:p>
           <a:p/>
@@ -1961,7 +1869,7 @@
           <a:lstStyle/>
           <a:p>
             <a:r>
-              <a:t>TIME: 5:00 (clock 30:00). Leave the QR code up.</a:t>
+              <a:t>TIME: 5:00 or more (talk ends at 24:10, so there are about 50 seconds of slack). Leave the QR code up.</a:t>
             </a:r>
           </a:p>
           <a:p/>
@@ -2228,13 +2136,13 @@
           <a:lstStyle/>
           <a:p>
             <a:r>
-              <a:t>TIME: 1:00 (clock 3:00)</a:t>
+              <a:t>TIME: 1:00 (clock 16:40)</a:t>
             </a:r>
           </a:p>
           <a:p/>
           <a:p>
             <a:r>
-              <a:t>Here's one sentence a teacher could type. (Read it.)</a:t>
+              <a:t>So how did these get made? Here's one sentence a teacher could type. (Read it.)</a:t>
             </a:r>
           </a:p>
           <a:p/>
@@ -2310,7 +2218,7 @@
           <a:lstStyle/>
           <a:p>
             <a:r>
-              <a:t>TIME: 2:30 (clock 5:30)</a:t>
+              <a:t>TIME: 2:30 (clock 19:10)</a:t>
             </a:r>
           </a:p>
           <a:p/>
@@ -2412,13 +2320,13 @@
           <a:lstStyle/>
           <a:p>
             <a:r>
-              <a:t>TIME: 1:15 (clock 6:45)</a:t>
+              <a:t>TIME: 1:15 (clock 3:15)</a:t>
             </a:r>
           </a:p>
           <a:p/>
           <a:p>
             <a:r>
-              <a:t>So what's the catch?</a:t>
+              <a:t>So AI can build the activity. Here's what Zest solves.</a:t>
             </a:r>
           </a:p>
           <a:p/>
@@ -2440,7 +2348,7 @@
           <a:p/>
           <a:p>
             <a:r>
-              <a:t>[CLICK] An interactive on its own is just a web page. That's the problem Zest solves.</a:t>
+              <a:t>[CLICK] AI can build the interactive, but on its own it's just a web page. Zest is what turns it into coursework.</a:t>
             </a:r>
           </a:p>
         </p:txBody>
@@ -2498,7 +2406,7 @@
           <a:lstStyle/>
           <a:p>
             <a:r>
-              <a:t>TIME: 1:45 (clock 8:30)</a:t>
+              <a:t>TIME: 1:45 (clock 5:00)</a:t>
             </a:r>
           </a:p>
           <a:p/>
@@ -2595,7 +2503,7 @@
           <a:lstStyle/>
           <a:p>
             <a:r>
-              <a:t>TIME: 1:00 (clock 9:30)</a:t>
+              <a:t>TIME: 1:00 (clock 6:00)</a:t>
             </a:r>
           </a:p>
           <a:p/>
@@ -2683,7 +2591,7 @@
           <a:lstStyle/>
           <a:p>
             <a:r>
-              <a:t>TIME: 3:00 (clock 12:30)</a:t>
+              <a:t>TIME: 3:00 (clock 9:00)</a:t>
             </a:r>
           </a:p>
           <a:p/>
@@ -25578,7 +25486,7 @@
                 </a:solidFill>
                 <a:latin typeface="Roboto"/>
               </a:rPr>
-              <a:t>Same sentence as before, plus a few answers about rounds and practice shots.</a:t>
+              <a:t>Built from this sentence plus a few answers about rounds and practice shots.</a:t>
             </a:r>
           </a:p>
         </p:txBody>
@@ -28195,853 +28103,6 @@
                                         <p:cTn id="8" dur="500"/>
                                         <p:tgtEl>
                                           <p:spTgt spid="257"/>
-                                        </p:tgtEl>
-                                      </p:cBhvr>
-                                    </p:animEffect>
-                                  </p:childTnLst>
-                                </p:cTn>
-                              </p:par>
-                            </p:childTnLst>
-                          </p:cTn>
-                        </p:par>
-                      </p:childTnLst>
-                    </p:cTn>
-                  </p:par>
-                </p:childTnLst>
-              </p:cTn>
-              <p:prevCondLst>
-                <p:cond evt="onPrev" delay="0">
-                  <p:tgtEl>
-                    <p:sldTgt/>
-                  </p:tgtEl>
-                </p:cond>
-              </p:prevCondLst>
-              <p:nextCondLst>
-                <p:cond evt="onNext" delay="0">
-                  <p:tgtEl>
-                    <p:sldTgt/>
-                  </p:tgtEl>
-                </p:cond>
-              </p:nextCondLst>
-            </p:seq>
-          </p:childTnLst>
-        </p:cTn>
-      </p:par>
-    </p:tnLst>
-  </p:timing>
-</p:sld>
-</file>
-
-<file path=ppt/slides/slide17.xml><?xml version="1.0" encoding="utf-8"?>
-<p:sld xmlns:a="http://schemas.openxmlformats.org/drawingml/2006/main" xmlns:r="http://schemas.openxmlformats.org/officeDocument/2006/relationships" xmlns:mc="http://schemas.openxmlformats.org/markup-compatibility/2006" xmlns:mv="urn:schemas-microsoft-com:mac:vml" xmlns:p="http://schemas.openxmlformats.org/presentationml/2006/main" xmlns:c="http://schemas.openxmlformats.org/drawingml/2006/chart" xmlns:dgm="http://schemas.openxmlformats.org/drawingml/2006/diagram" xmlns:o="urn:schemas-microsoft-com:office:office" xmlns:v="urn:schemas-microsoft-com:vml" xmlns:pvml="urn:schemas-microsoft-com:office:powerpoint" xmlns:com="http://schemas.openxmlformats.org/drawingml/2006/compatibility" xmlns:p14="http://schemas.microsoft.com/office/powerpoint/2010/main" xmlns:p15="http://schemas.microsoft.com/office/powerpoint/2012/main" xmlns:ahyp="http://schemas.microsoft.com/office/drawing/2018/hyperlinkcolor">
-  <p:cSld>
-    <p:spTree>
-      <p:nvGrpSpPr>
-        <p:cNvPr id="322" name="Shape 322"/>
-        <p:cNvGrpSpPr/>
-        <p:nvPr/>
-      </p:nvGrpSpPr>
-      <p:grpSpPr>
-        <a:xfrm>
-          <a:off x="0" y="0"/>
-          <a:ext cx="0" cy="0"/>
-          <a:chOff x="0" y="0"/>
-          <a:chExt cx="0" cy="0"/>
-        </a:xfrm>
-      </p:grpSpPr>
-      <p:sp>
-        <p:nvSpPr>
-          <p:cNvPr id="323" name="Google Shape;323;p44"/>
-          <p:cNvSpPr/>
-          <p:nvPr/>
-        </p:nvSpPr>
-        <p:spPr>
-          <a:xfrm>
-            <a:off x="0" y="4186673"/>
-            <a:ext cx="9144000" cy="957000"/>
-          </a:xfrm>
-          <a:prstGeom prst="rect">
-            <a:avLst/>
-          </a:prstGeom>
-          <a:solidFill>
-            <a:srgbClr val="25B5FF"/>
-          </a:solidFill>
-          <a:ln>
-            <a:noFill/>
-          </a:ln>
-        </p:spPr>
-        <p:txBody>
-          <a:bodyPr anchorCtr="0" anchor="ctr" bIns="45725" lIns="45725" spcFirstLastPara="1" rIns="45725" wrap="square" tIns="45725">
-            <a:noAutofit/>
-          </a:bodyPr>
-          <a:lstStyle/>
-          <a:p>
-            <a:pPr indent="0" lvl="0" marL="0" rtl="0" algn="l">
-              <a:spcBef>
-                <a:spcPts val="0"/>
-              </a:spcBef>
-              <a:spcAft>
-                <a:spcPts val="0"/>
-              </a:spcAft>
-              <a:buNone/>
-            </a:pPr>
-            <a:r>
-              <a:t/>
-            </a:r>
-            <a:endParaRPr/>
-          </a:p>
-        </p:txBody>
-      </p:sp>
-      <p:sp>
-        <p:nvSpPr>
-          <p:cNvPr id="324" name="Google Shape;324;p44"/>
-          <p:cNvSpPr/>
-          <p:nvPr/>
-        </p:nvSpPr>
-        <p:spPr>
-          <a:xfrm>
-            <a:off x="0" y="1942211"/>
-            <a:ext cx="9144000" cy="2244600"/>
-          </a:xfrm>
-          <a:prstGeom prst="rect">
-            <a:avLst/>
-          </a:prstGeom>
-          <a:solidFill>
-            <a:srgbClr val="000000"/>
-          </a:solidFill>
-          <a:ln>
-            <a:noFill/>
-          </a:ln>
-        </p:spPr>
-        <p:txBody>
-          <a:bodyPr anchorCtr="0" anchor="ctr" bIns="45725" lIns="45725" spcFirstLastPara="1" rIns="45725" wrap="square" tIns="45725">
-            <a:noAutofit/>
-          </a:bodyPr>
-          <a:lstStyle/>
-          <a:p>
-            <a:pPr indent="0" lvl="0" marL="0" rtl="0" algn="l">
-              <a:spcBef>
-                <a:spcPts val="0"/>
-              </a:spcBef>
-              <a:spcAft>
-                <a:spcPts val="0"/>
-              </a:spcAft>
-              <a:buNone/>
-            </a:pPr>
-            <a:r>
-              <a:t/>
-            </a:r>
-            <a:endParaRPr/>
-          </a:p>
-        </p:txBody>
-      </p:sp>
-      <p:pic>
-        <p:nvPicPr>
-          <p:cNvPr id="328" name="Google Shape;328;p44"/>
-          <p:cNvPicPr preferRelativeResize="0"/>
-          <p:nvPr/>
-        </p:nvPicPr>
-        <p:blipFill rotWithShape="1">
-          <a:blip r:embed="rId3">
-            <a:alphaModFix/>
-          </a:blip>
-          <a:srcRect b="0" l="0" r="0" t="0"/>
-          <a:stretch/>
-        </p:blipFill>
-        <p:spPr>
-          <a:xfrm rot="-5400000">
-            <a:off x="8155279" y="0"/>
-            <a:ext cx="988721" cy="988721"/>
-          </a:xfrm>
-          <a:prstGeom prst="rect">
-            <a:avLst/>
-          </a:prstGeom>
-          <a:noFill/>
-          <a:ln>
-            <a:noFill/>
-          </a:ln>
-        </p:spPr>
-      </p:pic>
-      <p:pic>
-        <p:nvPicPr>
-          <p:cNvPr id="329" name="Google Shape;329;p44"/>
-          <p:cNvPicPr preferRelativeResize="0"/>
-          <p:nvPr/>
-        </p:nvPicPr>
-        <p:blipFill rotWithShape="1">
-          <a:blip r:embed="rId4">
-            <a:alphaModFix/>
-          </a:blip>
-          <a:srcRect b="0" l="0" r="0" t="0"/>
-          <a:stretch/>
-        </p:blipFill>
-        <p:spPr>
-          <a:xfrm>
-            <a:off x="8251663" y="1753217"/>
-            <a:ext cx="377988" cy="377988"/>
-          </a:xfrm>
-          <a:prstGeom prst="rect">
-            <a:avLst/>
-          </a:prstGeom>
-          <a:noFill/>
-          <a:ln>
-            <a:noFill/>
-          </a:ln>
-        </p:spPr>
-      </p:pic>
-      <p:grpSp>
-        <p:nvGrpSpPr>
-          <p:cNvPr id="336" name="Google Shape;336;p44"/>
-          <p:cNvGrpSpPr/>
-          <p:nvPr/>
-        </p:nvGrpSpPr>
-        <p:grpSpPr>
-          <a:xfrm>
-            <a:off x="7704129" y="4183226"/>
-            <a:ext cx="915496" cy="471026"/>
-            <a:chOff x="61924" y="79616"/>
-            <a:chExt cx="2441323" cy="1256068"/>
-          </a:xfrm>
-        </p:grpSpPr>
-        <p:sp>
-          <p:nvSpPr>
-            <p:cNvPr id="337" name="Google Shape;337;p44"/>
-            <p:cNvSpPr/>
-            <p:nvPr/>
-          </p:nvSpPr>
-          <p:spPr>
-            <a:xfrm>
-              <a:off x="61924" y="79616"/>
-              <a:ext cx="2441323" cy="1256068"/>
-            </a:xfrm>
-            <a:custGeom>
-              <a:rect b="b" l="l" r="r" t="t"/>
-              <a:pathLst>
-                <a:path extrusionOk="0" h="360680" w="701026">
-                  <a:moveTo>
-                    <a:pt x="701026" y="180340"/>
-                  </a:moveTo>
-                  <a:cubicBezTo>
-                    <a:pt x="701026" y="81280"/>
-                    <a:pt x="621016" y="0"/>
-                    <a:pt x="520686" y="0"/>
-                  </a:cubicBezTo>
-                  <a:lnTo>
-                    <a:pt x="172720" y="0"/>
-                  </a:lnTo>
-                  <a:lnTo>
-                    <a:pt x="172720" y="1270"/>
-                  </a:lnTo>
-                  <a:cubicBezTo>
-                    <a:pt x="76200" y="5080"/>
-                    <a:pt x="0" y="83820"/>
-                    <a:pt x="0" y="180340"/>
-                  </a:cubicBezTo>
-                  <a:cubicBezTo>
-                    <a:pt x="0" y="276860"/>
-                    <a:pt x="77470" y="355600"/>
-                    <a:pt x="172720" y="359410"/>
-                  </a:cubicBezTo>
-                  <a:lnTo>
-                    <a:pt x="172720" y="360680"/>
-                  </a:lnTo>
-                  <a:lnTo>
-                    <a:pt x="520685" y="360680"/>
-                  </a:lnTo>
-                  <a:cubicBezTo>
-                    <a:pt x="619745" y="360680"/>
-                    <a:pt x="701025" y="279400"/>
-                    <a:pt x="701025" y="180340"/>
-                  </a:cubicBezTo>
-                  <a:close/>
-                </a:path>
-              </a:pathLst>
-            </a:custGeom>
-            <a:solidFill>
-              <a:srgbClr val="C0C0C0">
-                <a:alpha val="25490"/>
-              </a:srgbClr>
-            </a:solidFill>
-            <a:ln>
-              <a:noFill/>
-            </a:ln>
-          </p:spPr>
-          <p:txBody>
-            <a:bodyPr anchorCtr="0" anchor="ctr" bIns="45725" lIns="45725" spcFirstLastPara="1" rIns="45725" wrap="square" tIns="45725">
-              <a:noAutofit/>
-            </a:bodyPr>
-            <a:lstStyle/>
-            <a:p>
-              <a:pPr indent="0" lvl="0" marL="0" rtl="0" algn="l">
-                <a:spcBef>
-                  <a:spcPts val="0"/>
-                </a:spcBef>
-                <a:spcAft>
-                  <a:spcPts val="0"/>
-                </a:spcAft>
-                <a:buNone/>
-              </a:pPr>
-              <a:r>
-                <a:t/>
-              </a:r>
-              <a:endParaRPr/>
-            </a:p>
-          </p:txBody>
-        </p:sp>
-        <p:pic>
-          <p:nvPicPr>
-            <p:cNvPr id="338" name="Google Shape;338;p44"/>
-            <p:cNvPicPr preferRelativeResize="0"/>
-            <p:nvPr/>
-          </p:nvPicPr>
-          <p:blipFill rotWithShape="1">
-            <a:blip r:embed="rId5">
-              <a:alphaModFix/>
-            </a:blip>
-            <a:srcRect b="0" l="0" r="0" t="0"/>
-            <a:stretch/>
-          </p:blipFill>
-          <p:spPr>
-            <a:xfrm>
-              <a:off x="1328489" y="190500"/>
-              <a:ext cx="1034400" cy="1034400"/>
-            </a:xfrm>
-            <a:prstGeom prst="rect">
-              <a:avLst/>
-            </a:prstGeom>
-            <a:noFill/>
-            <a:ln>
-              <a:noFill/>
-            </a:ln>
-          </p:spPr>
-        </p:pic>
-      </p:grpSp>
-      <p:pic>
-        <p:nvPicPr>
-          <p:cNvPr id="339" name="Google Shape;339;p44"/>
-          <p:cNvPicPr preferRelativeResize="0"/>
-          <p:nvPr/>
-        </p:nvPicPr>
-        <p:blipFill rotWithShape="1">
-          <a:blip r:embed="rId6">
-            <a:alphaModFix/>
-          </a:blip>
-          <a:srcRect b="0" l="0" r="0" t="0"/>
-          <a:stretch/>
-        </p:blipFill>
-        <p:spPr>
-          <a:xfrm>
-            <a:off x="8236813" y="4282529"/>
-            <a:ext cx="272458" cy="272458"/>
-          </a:xfrm>
-          <a:prstGeom prst="rect">
-            <a:avLst/>
-          </a:prstGeom>
-          <a:noFill/>
-          <a:ln>
-            <a:noFill/>
-          </a:ln>
-        </p:spPr>
-      </p:pic>
-      <p:pic>
-        <p:nvPicPr>
-          <p:cNvPr id="340" name="Google Shape;340;p44"/>
-          <p:cNvPicPr preferRelativeResize="0"/>
-          <p:nvPr/>
-        </p:nvPicPr>
-        <p:blipFill rotWithShape="1">
-          <a:blip r:embed="rId7">
-            <a:alphaModFix/>
-          </a:blip>
-          <a:srcRect b="0" l="0" r="0" t="0"/>
-          <a:stretch/>
-        </p:blipFill>
-        <p:spPr>
-          <a:xfrm>
-            <a:off x="79132" y="4418758"/>
-            <a:ext cx="1078263" cy="653248"/>
-          </a:xfrm>
-          <a:prstGeom prst="rect">
-            <a:avLst/>
-          </a:prstGeom>
-          <a:noFill/>
-          <a:ln>
-            <a:noFill/>
-          </a:ln>
-        </p:spPr>
-      </p:pic>
-      <p:sp>
-        <p:nvSpPr>
-          <p:cNvPr id="341" name="TextBox 340"/>
-          <p:cNvSpPr txBox="1"/>
-          <p:nvPr/>
-        </p:nvSpPr>
-        <p:spPr>
-          <a:xfrm>
-            <a:off x="512064" y="502920"/>
-            <a:ext cx="6858000" cy="548640"/>
-          </a:xfrm>
-          <a:prstGeom prst="rect">
-            <a:avLst/>
-          </a:prstGeom>
-          <a:noFill/>
-        </p:spPr>
-        <p:txBody>
-          <a:bodyPr wrap="square" anchor="t" lIns="0" rIns="0" tIns="0" bIns="0">
-            <a:spAutoFit/>
-          </a:bodyPr>
-          <a:lstStyle/>
-          <a:p>
-            <a:pPr algn="l">
-              <a:spcAft>
-                <a:spcPts val="0"/>
-              </a:spcAft>
-            </a:pPr>
-            <a:r>
-              <a:rPr sz="3000" b="1" i="0">
-                <a:solidFill>
-                  <a:srgbClr val="131313"/>
-                </a:solidFill>
-                <a:latin typeface="League Spartan"/>
-              </a:rPr>
-              <a:t>Why Build It Ourselves?</a:t>
-            </a:r>
-          </a:p>
-        </p:txBody>
-      </p:sp>
-      <p:sp>
-        <p:nvSpPr>
-          <p:cNvPr id="342" name="TextBox 341"/>
-          <p:cNvSpPr txBox="1"/>
-          <p:nvPr/>
-        </p:nvSpPr>
-        <p:spPr>
-          <a:xfrm>
-            <a:off x="512064" y="2240280"/>
-            <a:ext cx="3566160" cy="777240"/>
-          </a:xfrm>
-          <a:prstGeom prst="rect">
-            <a:avLst/>
-          </a:prstGeom>
-          <a:noFill/>
-        </p:spPr>
-        <p:txBody>
-          <a:bodyPr wrap="square" anchor="t" lIns="0" rIns="0" tIns="0" bIns="0">
-            <a:spAutoFit/>
-          </a:bodyPr>
-          <a:lstStyle/>
-          <a:p>
-            <a:pPr algn="l">
-              <a:spcAft>
-                <a:spcPts val="200"/>
-              </a:spcAft>
-            </a:pPr>
-            <a:r>
-              <a:rPr sz="1800" b="1" i="0">
-                <a:solidFill>
-                  <a:srgbClr val="FFFFFF"/>
-                </a:solidFill>
-                <a:latin typeface="League Spartan"/>
-              </a:rPr>
-              <a:t>Grades inside Canvas</a:t>
-            </a:r>
-          </a:p>
-          <a:p>
-            <a:pPr algn="l">
-              <a:spcAft>
-                <a:spcPts val="600"/>
-              </a:spcAft>
-            </a:pPr>
-            <a:r>
-              <a:rPr sz="1200" b="0" i="0">
-                <a:solidFill>
-                  <a:srgbClr val="FFFFFF"/>
-                </a:solidFill>
-                <a:latin typeface="Roboto"/>
-              </a:rPr>
-              <a:t>Not in another tool</a:t>
-            </a:r>
-          </a:p>
-        </p:txBody>
-      </p:sp>
-      <p:sp>
-        <p:nvSpPr>
-          <p:cNvPr id="343" name="TextBox 342"/>
-          <p:cNvSpPr txBox="1"/>
-          <p:nvPr/>
-        </p:nvSpPr>
-        <p:spPr>
-          <a:xfrm>
-            <a:off x="512064" y="3063240"/>
-            <a:ext cx="3566160" cy="777240"/>
-          </a:xfrm>
-          <a:prstGeom prst="rect">
-            <a:avLst/>
-          </a:prstGeom>
-          <a:noFill/>
-        </p:spPr>
-        <p:txBody>
-          <a:bodyPr wrap="square" anchor="t" lIns="0" rIns="0" tIns="0" bIns="0">
-            <a:spAutoFit/>
-          </a:bodyPr>
-          <a:lstStyle/>
-          <a:p>
-            <a:pPr algn="l">
-              <a:spcAft>
-                <a:spcPts val="200"/>
-              </a:spcAft>
-            </a:pPr>
-            <a:r>
-              <a:rPr sz="1800" b="1" i="0">
-                <a:solidFill>
-                  <a:srgbClr val="FFFFFF"/>
-                </a:solidFill>
-                <a:latin typeface="League Spartan"/>
-              </a:rPr>
-              <a:t>Our data, our server</a:t>
-            </a:r>
-          </a:p>
-          <a:p>
-            <a:pPr algn="l">
-              <a:spcAft>
-                <a:spcPts val="600"/>
-              </a:spcAft>
-            </a:pPr>
-            <a:r>
-              <a:rPr sz="1200" b="0" i="0">
-                <a:solidFill>
-                  <a:srgbClr val="FFFFFF"/>
-                </a:solidFill>
-                <a:latin typeface="Roboto"/>
-              </a:rPr>
-              <a:t>Student work stays with us</a:t>
-            </a:r>
-          </a:p>
-        </p:txBody>
-      </p:sp>
-      <p:sp>
-        <p:nvSpPr>
-          <p:cNvPr id="344" name="TextBox 343"/>
-          <p:cNvSpPr txBox="1"/>
-          <p:nvPr/>
-        </p:nvSpPr>
-        <p:spPr>
-          <a:xfrm>
-            <a:off x="5157216" y="2240280"/>
-            <a:ext cx="3566160" cy="777240"/>
-          </a:xfrm>
-          <a:prstGeom prst="rect">
-            <a:avLst/>
-          </a:prstGeom>
-          <a:noFill/>
-        </p:spPr>
-        <p:txBody>
-          <a:bodyPr wrap="square" anchor="t" lIns="0" rIns="0" tIns="0" bIns="0">
-            <a:spAutoFit/>
-          </a:bodyPr>
-          <a:lstStyle/>
-          <a:p>
-            <a:pPr algn="l">
-              <a:spcAft>
-                <a:spcPts val="200"/>
-              </a:spcAft>
-            </a:pPr>
-            <a:r>
-              <a:rPr sz="1800" b="1" i="0">
-                <a:solidFill>
-                  <a:srgbClr val="FFFFFF"/>
-                </a:solidFill>
-                <a:latin typeface="League Spartan"/>
-              </a:rPr>
-              <a:t>No per-seat license</a:t>
-            </a:r>
-          </a:p>
-          <a:p>
-            <a:pPr algn="l">
-              <a:spcAft>
-                <a:spcPts val="600"/>
-              </a:spcAft>
-            </a:pPr>
-            <a:r>
-              <a:rPr sz="1200" b="0" i="0">
-                <a:solidFill>
-                  <a:srgbClr val="FFFFFF"/>
-                </a:solidFill>
-                <a:latin typeface="Roboto"/>
-              </a:rPr>
-              <a:t>Add students without a new contract</a:t>
-            </a:r>
-          </a:p>
-        </p:txBody>
-      </p:sp>
-      <p:sp>
-        <p:nvSpPr>
-          <p:cNvPr id="345" name="TextBox 344"/>
-          <p:cNvSpPr txBox="1"/>
-          <p:nvPr/>
-        </p:nvSpPr>
-        <p:spPr>
-          <a:xfrm>
-            <a:off x="5157216" y="3063240"/>
-            <a:ext cx="3566160" cy="777240"/>
-          </a:xfrm>
-          <a:prstGeom prst="rect">
-            <a:avLst/>
-          </a:prstGeom>
-          <a:noFill/>
-        </p:spPr>
-        <p:txBody>
-          <a:bodyPr wrap="square" anchor="t" lIns="0" rIns="0" tIns="0" bIns="0">
-            <a:spAutoFit/>
-          </a:bodyPr>
-          <a:lstStyle/>
-          <a:p>
-            <a:pPr algn="l">
-              <a:spcAft>
-                <a:spcPts val="200"/>
-              </a:spcAft>
-            </a:pPr>
-            <a:r>
-              <a:rPr sz="1800" b="1" i="0">
-                <a:solidFill>
-                  <a:srgbClr val="FFFFFF"/>
-                </a:solidFill>
-                <a:latin typeface="League Spartan"/>
-              </a:rPr>
-              <a:t>Content needed a home</a:t>
-            </a:r>
-          </a:p>
-          <a:p>
-            <a:pPr algn="l">
-              <a:spcAft>
-                <a:spcPts val="600"/>
-              </a:spcAft>
-            </a:pPr>
-            <a:r>
-              <a:rPr sz="1200" b="0" i="0">
-                <a:solidFill>
-                  <a:srgbClr val="FFFFFF"/>
-                </a:solidFill>
-                <a:latin typeface="Roboto"/>
-              </a:rPr>
-              <a:t>We already had it</a:t>
-            </a:r>
-          </a:p>
-        </p:txBody>
-      </p:sp>
-    </p:spTree>
-  </p:cSld>
-  <p:clrMapOvr>
-    <a:masterClrMapping/>
-  </p:clrMapOvr>
-  <p:timing>
-    <p:tnLst>
-      <p:par>
-        <p:cTn id="1" dur="indefinite" restart="never" nodeType="tmRoot">
-          <p:childTnLst>
-            <p:seq concurrent="1" nextAc="seek">
-              <p:cTn id="2" dur="indefinite" nodeType="mainSeq">
-                <p:childTnLst>
-                  <p:par>
-                    <p:cTn id="6" fill="hold">
-                      <p:stCondLst>
-                        <p:cond delay="indefinite"/>
-                      </p:stCondLst>
-                      <p:childTnLst>
-                        <p:par>
-                          <p:cTn id="7" fill="hold">
-                            <p:stCondLst>
-                              <p:cond delay="0"/>
-                            </p:stCondLst>
-                            <p:childTnLst>
-                              <p:par>
-                                <p:cTn id="3" presetID="10" presetClass="entr" presetSubtype="0" fill="hold" nodeType="clickEffect">
-                                  <p:stCondLst>
-                                    <p:cond delay="0"/>
-                                  </p:stCondLst>
-                                  <p:childTnLst>
-                                    <p:set>
-                                      <p:cBhvr>
-                                        <p:cTn id="4" dur="1" fill="hold">
-                                          <p:stCondLst>
-                                            <p:cond delay="0"/>
-                                          </p:stCondLst>
-                                        </p:cTn>
-                                        <p:tgtEl>
-                                          <p:spTgt spid="342"/>
-                                        </p:tgtEl>
-                                        <p:attrNameLst>
-                                          <p:attrName>style.visibility</p:attrName>
-                                        </p:attrNameLst>
-                                      </p:cBhvr>
-                                      <p:to>
-                                        <p:strVal val="visible"/>
-                                      </p:to>
-                                    </p:set>
-                                    <p:animEffect transition="in" filter="fade">
-                                      <p:cBhvr>
-                                        <p:cTn id="5" dur="500"/>
-                                        <p:tgtEl>
-                                          <p:spTgt spid="342"/>
-                                        </p:tgtEl>
-                                      </p:cBhvr>
-                                    </p:animEffect>
-                                  </p:childTnLst>
-                                </p:cTn>
-                              </p:par>
-                            </p:childTnLst>
-                          </p:cTn>
-                        </p:par>
-                      </p:childTnLst>
-                    </p:cTn>
-                  </p:par>
-                  <p:par>
-                    <p:cTn id="11" fill="hold">
-                      <p:stCondLst>
-                        <p:cond delay="indefinite"/>
-                      </p:stCondLst>
-                      <p:childTnLst>
-                        <p:par>
-                          <p:cTn id="12" fill="hold">
-                            <p:stCondLst>
-                              <p:cond delay="0"/>
-                            </p:stCondLst>
-                            <p:childTnLst>
-                              <p:par>
-                                <p:cTn id="8" presetID="10" presetClass="entr" presetSubtype="0" fill="hold" nodeType="clickEffect">
-                                  <p:stCondLst>
-                                    <p:cond delay="0"/>
-                                  </p:stCondLst>
-                                  <p:childTnLst>
-                                    <p:set>
-                                      <p:cBhvr>
-                                        <p:cTn id="9" dur="1" fill="hold">
-                                          <p:stCondLst>
-                                            <p:cond delay="0"/>
-                                          </p:stCondLst>
-                                        </p:cTn>
-                                        <p:tgtEl>
-                                          <p:spTgt spid="343"/>
-                                        </p:tgtEl>
-                                        <p:attrNameLst>
-                                          <p:attrName>style.visibility</p:attrName>
-                                        </p:attrNameLst>
-                                      </p:cBhvr>
-                                      <p:to>
-                                        <p:strVal val="visible"/>
-                                      </p:to>
-                                    </p:set>
-                                    <p:animEffect transition="in" filter="fade">
-                                      <p:cBhvr>
-                                        <p:cTn id="10" dur="500"/>
-                                        <p:tgtEl>
-                                          <p:spTgt spid="343"/>
-                                        </p:tgtEl>
-                                      </p:cBhvr>
-                                    </p:animEffect>
-                                  </p:childTnLst>
-                                </p:cTn>
-                              </p:par>
-                            </p:childTnLst>
-                          </p:cTn>
-                        </p:par>
-                      </p:childTnLst>
-                    </p:cTn>
-                  </p:par>
-                  <p:par>
-                    <p:cTn id="16" fill="hold">
-                      <p:stCondLst>
-                        <p:cond delay="indefinite"/>
-                      </p:stCondLst>
-                      <p:childTnLst>
-                        <p:par>
-                          <p:cTn id="17" fill="hold">
-                            <p:stCondLst>
-                              <p:cond delay="0"/>
-                            </p:stCondLst>
-                            <p:childTnLst>
-                              <p:par>
-                                <p:cTn id="13" presetID="10" presetClass="entr" presetSubtype="0" fill="hold" nodeType="clickEffect">
-                                  <p:stCondLst>
-                                    <p:cond delay="0"/>
-                                  </p:stCondLst>
-                                  <p:childTnLst>
-                                    <p:set>
-                                      <p:cBhvr>
-                                        <p:cTn id="14" dur="1" fill="hold">
-                                          <p:stCondLst>
-                                            <p:cond delay="0"/>
-                                          </p:stCondLst>
-                                        </p:cTn>
-                                        <p:tgtEl>
-                                          <p:spTgt spid="344"/>
-                                        </p:tgtEl>
-                                        <p:attrNameLst>
-                                          <p:attrName>style.visibility</p:attrName>
-                                        </p:attrNameLst>
-                                      </p:cBhvr>
-                                      <p:to>
-                                        <p:strVal val="visible"/>
-                                      </p:to>
-                                    </p:set>
-                                    <p:animEffect transition="in" filter="fade">
-                                      <p:cBhvr>
-                                        <p:cTn id="15" dur="500"/>
-                                        <p:tgtEl>
-                                          <p:spTgt spid="344"/>
-                                        </p:tgtEl>
-                                      </p:cBhvr>
-                                    </p:animEffect>
-                                  </p:childTnLst>
-                                </p:cTn>
-                              </p:par>
-                            </p:childTnLst>
-                          </p:cTn>
-                        </p:par>
-                      </p:childTnLst>
-                    </p:cTn>
-                  </p:par>
-                  <p:par>
-                    <p:cTn id="21" fill="hold">
-                      <p:stCondLst>
-                        <p:cond delay="indefinite"/>
-                      </p:stCondLst>
-                      <p:childTnLst>
-                        <p:par>
-                          <p:cTn id="22" fill="hold">
-                            <p:stCondLst>
-                              <p:cond delay="0"/>
-                            </p:stCondLst>
-                            <p:childTnLst>
-                              <p:par>
-                                <p:cTn id="18" presetID="10" presetClass="entr" presetSubtype="0" fill="hold" nodeType="clickEffect">
-                                  <p:stCondLst>
-                                    <p:cond delay="0"/>
-                                  </p:stCondLst>
-                                  <p:childTnLst>
-                                    <p:set>
-                                      <p:cBhvr>
-                                        <p:cTn id="19" dur="1" fill="hold">
-                                          <p:stCondLst>
-                                            <p:cond delay="0"/>
-                                          </p:stCondLst>
-                                        </p:cTn>
-                                        <p:tgtEl>
-                                          <p:spTgt spid="345"/>
-                                        </p:tgtEl>
-                                        <p:attrNameLst>
-                                          <p:attrName>style.visibility</p:attrName>
-                                        </p:attrNameLst>
-                                      </p:cBhvr>
-                                      <p:to>
-                                        <p:strVal val="visible"/>
-                                      </p:to>
-                                    </p:set>
-                                    <p:animEffect transition="in" filter="fade">
-                                      <p:cBhvr>
-                                        <p:cTn id="20" dur="500"/>
-                                        <p:tgtEl>
-                                          <p:spTgt spid="345"/>
                                         </p:tgtEl>
                                       </p:cBhvr>
                                     </p:animEffect>
@@ -30971,61 +30032,6 @@
                 <a:latin typeface="Roboto"/>
               </a:rPr>
               <a:t>kyle.yancey@virtualarkansas.org</a:t>
-            </a:r>
-          </a:p>
-        </p:txBody>
-      </p:sp>
-      <p:sp>
-        <p:nvSpPr>
-          <p:cNvPr id="557" name="Oval 556"/>
-          <p:cNvSpPr/>
-          <p:nvPr/>
-        </p:nvSpPr>
-        <p:spPr>
-          <a:xfrm>
-            <a:off x="5486400" y="822960"/>
-            <a:ext cx="2377440" cy="2377440"/>
-          </a:xfrm>
-          <a:prstGeom prst="ellipse">
-            <a:avLst/>
-          </a:prstGeom>
-          <a:solidFill>
-            <a:srgbClr val="EEEEEE"/>
-          </a:solidFill>
-          <a:ln w="19050">
-            <a:solidFill>
-              <a:srgbClr val="25AEFA"/>
-            </a:solidFill>
-          </a:ln>
-          <a:effectLst/>
-        </p:spPr>
-        <p:style>
-          <a:lnRef idx="1">
-            <a:schemeClr val="accent1"/>
-          </a:lnRef>
-          <a:fillRef idx="3">
-            <a:schemeClr val="accent1"/>
-          </a:fillRef>
-          <a:effectRef idx="2">
-            <a:schemeClr val="accent1"/>
-          </a:effectRef>
-          <a:fontRef idx="minor">
-            <a:schemeClr val="lt1"/>
-          </a:fontRef>
-        </p:style>
-        <p:txBody>
-          <a:bodyPr rtlCol="0" anchor="ctr"/>
-          <a:lstStyle/>
-          <a:p>
-            <a:pPr algn="ctr"/>
-            <a:r>
-              <a:rPr sz="1200">
-                <a:solidFill>
-                  <a:srgbClr val="605F5E"/>
-                </a:solidFill>
-                <a:latin typeface="Roboto"/>
-              </a:rPr>
-              <a:t>Your photo</a:t>
             </a:r>
           </a:p>
         </p:txBody>
@@ -36729,7 +35735,7 @@
                 </a:solidFill>
                 <a:latin typeface="League Spartan"/>
               </a:rPr>
-              <a:t>So What's the Catch?</a:t>
+              <a:t>What Zest Solves</a:t>
             </a:r>
           </a:p>
         </p:txBody>
@@ -36742,8 +35748,8 @@
         </p:nvSpPr>
         <p:spPr>
           <a:xfrm>
-            <a:off x="5486400" y="1920240"/>
-            <a:ext cx="3017520" cy="1097280"/>
+            <a:off x="5486400" y="1600200"/>
+            <a:ext cx="3017520" cy="1463040"/>
           </a:xfrm>
           <a:prstGeom prst="rect">
             <a:avLst/>
@@ -36768,7 +35774,7 @@
                 </a:solidFill>
                 <a:latin typeface="Roboto"/>
               </a:rPr>
-              <a:t>An interactive on its own is just a web page.</a:t>
+              <a:t>AI can build the interactive. On its own, it is just a web page.</a:t>
             </a:r>
           </a:p>
         </p:txBody>

</xml_diff>

<commit_message>
VLLA 2026: final deck changes for the talk
- QR codes for the four zests are added at build time from local files
  (the presented deck has them; the repository copy keeps placeholders)
- A short PhET mention on How It Started
- GitHub links for zest-spec and zest-creator on the Share slide
- Questions slide notes trimmed; open notes to Kyle removed

Co-Authored-By: Claude Opus 5.5 <noreply@anthropic.com>
Claude-Session: https://claude.ai/code/session_01L5t2fWvgteFsVvQKqGnV28
</commit_message>
<xml_diff>
--- a/presentations/2026-vlla/deck/zest-vlla-2026.pptx
+++ b/presentations/2026-vlla/deck/zest-vlla-2026.pptx
@@ -852,12 +852,6 @@
           <a:p>
             <a:r>
               <a:t>The AI builds these too. In the prompt for Sketch &amp; Label, the teacher just said "in SpeedGrader I want to see their drawing and watch how they drew it."</a:t>
-            </a:r>
-          </a:p>
-          <a:p/>
-          <a:p>
-            <a:r>
-              <a:t>[Kyle: once the zests are on your sandbox, a screenshot of one of these inside real Canvas SpeedGrader would be the strongest image for this slide.]</a:t>
             </a:r>
           </a:p>
         </p:txBody>
@@ -1411,7 +1405,7 @@
           <a:p/>
           <a:p>
             <a:r>
-              <a:t>[Kyle: decide whether to show the GitHub links for zest-spec and zest-creator.]</a:t>
+              <a:t>Both links are on the slide: github.com/VirtualArkansasOrg/zest-spec and github.com/VirtualArkansasOrg/zest-creator.</a:t>
             </a:r>
           </a:p>
         </p:txBody>
@@ -1561,12 +1555,6 @@
           <a:p>
             <a:r>
               <a:t>Quick background so you know where I'm coming from. I taught for about ten years: physics, chemistry, biology, physical science, business and computer science. I've been writing code for about 25 years. These days I'm the Data Science Specialist at Virtual Arkansas, and most of what I build is AI tools for our teachers and students.</a:t>
-            </a:r>
-          </a:p>
-          <a:p/>
-          <a:p>
-            <a:r>
-              <a:t>[Kyle: update anything that's changed.]</a:t>
             </a:r>
           </a:p>
         </p:txBody>
@@ -1875,128 +1863,7 @@
           <a:p/>
           <a:p>
             <a:r>
-              <a:t>LIKELY QUESTIONS, SHORT ANSWERS</a:t>
-            </a:r>
-          </a:p>
-          <a:p/>
-          <a:p>
-            <a:r>
-              <a:t>What does Claude Code cost?</a:t>
-            </a:r>
-          </a:p>
-          <a:p>
-            <a:r>
-              <a:t>It needs a paid Claude plan. Check current pricing; it's a per-person subscription, not per student.</a:t>
-            </a:r>
-          </a:p>
-          <a:p/>
-          <a:p>
-            <a:r>
-              <a:t>Does student data go to the AI?</a:t>
-            </a:r>
-          </a:p>
-          <a:p>
-            <a:r>
-              <a:t>No. The AI only sees what the teacher types while building the activity. The Zest server has no AI in it and doesn't send student work anywhere.</a:t>
-            </a:r>
-          </a:p>
-          <a:p/>
-          <a:p>
-            <a:r>
-              <a:t>Who checks what the AI builds? Can it be wrong?</a:t>
-            </a:r>
-          </a:p>
-          <a:p>
-            <a:r>
-              <a:t>Yes, it can be wrong. The build checks and the security review catch technical problems. A teacher tests it as a student, and a subject expert checks the content, same as any material we'd put in a course.</a:t>
-            </a:r>
-          </a:p>
-          <a:p/>
-          <a:p>
-            <a:r>
-              <a:t>Hosting and cost?</a:t>
-            </a:r>
-          </a:p>
-          <a:p>
-            <a:r>
-              <a:t>It runs on your own server (Docker and PostgreSQL), with encrypted nightly backups. No per-seat license.</a:t>
-            </a:r>
-          </a:p>
-          <a:p/>
-          <a:p>
-            <a:r>
-              <a:t>Can we share zests with you, or use yours?</a:t>
-            </a:r>
-          </a:p>
-          <a:p>
-            <a:r>
-              <a:t>Yes. That's the point of the spec. A zest built for one Zest server runs on any other.</a:t>
-            </a:r>
-          </a:p>
-          <a:p/>
-          <a:p>
-            <a:r>
-              <a:t>Other LMSs?</a:t>
-            </a:r>
-          </a:p>
-          <a:p>
-            <a:r>
-              <a:t>Canvas only for now. We've researched Brightspace, Schoology and Buzz.</a:t>
-            </a:r>
-          </a:p>
-          <a:p/>
-          <a:p>
-            <a:r>
-              <a:t>Accessibility?</a:t>
-            </a:r>
-          </a:p>
-          <a:p>
-            <a:r>
-              <a:t>A review is planned. Zests are plain HTML, so they can be built accessibly, but I'm not claiming conformance yet.</a:t>
-            </a:r>
-          </a:p>
-          <a:p/>
-          <a:p>
-            <a:r>
-              <a:t>Can students cheat on auto-graded ones?</a:t>
-            </a:r>
-          </a:p>
-          <a:p>
-            <a:r>
-              <a:t>Scores are calculated in the browser, so a determined student could. Use teacher grading for high stakes.</a:t>
-            </a:r>
-          </a:p>
-          <a:p/>
-          <a:p>
-            <a:r>
-              <a:t>Can we upload any zest someone sends us?</a:t>
-            </a:r>
-          </a:p>
-          <a:p>
-            <a:r>
-              <a:t>Only upload packages you trust for now. Packages run on the same domain as the tool; a separate domain is the next security step.</a:t>
-            </a:r>
-          </a:p>
-          <a:p/>
-          <a:p>
-            <a:r>
-              <a:t>Support?</a:t>
-            </a:r>
-          </a:p>
-          <a:p>
-            <a:r>
-              <a:t>[Kyle: your answer.]</a:t>
-            </a:r>
-          </a:p>
-          <a:p/>
-          <a:p>
-            <a:r>
-              <a:t>When does the server code come out?</a:t>
-            </a:r>
-          </a:p>
-          <a:p>
-            <a:r>
-              <a:t>[Kyle: your answer.] Fill out the form and I'll let you know.</a:t>
+              <a:t>Take questions. Answer them in your own words.</a:t>
             </a:r>
           </a:p>
         </p:txBody>
@@ -2533,7 +2400,7 @@
           <a:p/>
           <a:p>
             <a:r>
-              <a:t>[Kyle: the session title says "From PhET to Keyboarding". If you want, mention where PhET-style simulations fit here.]</a:t>
+              <a:t>Along the way we tested it with PhET-style science simulations, with an explore mode the teacher grades and a challenge mode that grades itself. That's where the "From PhET" in the title comes from.</a:t>
             </a:r>
           </a:p>
         </p:txBody>
@@ -28565,11 +28432,11 @@
           <a:p>
             <a:pPr algn="l">
               <a:spcAft>
-                <a:spcPts val="1400"/>
+                <a:spcPts val="200"/>
               </a:spcAft>
             </a:pPr>
             <a:r>
-              <a:rPr sz="1500" b="0" i="0">
+              <a:rPr sz="1400" b="0" i="0">
                 <a:solidFill>
                   <a:srgbClr val="FFFFFF"/>
                 </a:solidFill>
@@ -28581,11 +28448,27 @@
           <a:p>
             <a:pPr algn="l">
               <a:spcAft>
-                <a:spcPts val="1400"/>
+                <a:spcPts val="1000"/>
               </a:spcAft>
             </a:pPr>
             <a:r>
-              <a:rPr sz="1500" b="0" i="0">
+              <a:rPr sz="1100" b="0" i="0">
+                <a:solidFill>
+                  <a:srgbClr val="25AEFA"/>
+                </a:solidFill>
+                <a:latin typeface="Roboto"/>
+              </a:rPr>
+              <a:t>github.com/VirtualArkansasOrg/zest-spec</a:t>
+            </a:r>
+          </a:p>
+          <a:p>
+            <a:pPr algn="l">
+              <a:spcAft>
+                <a:spcPts val="200"/>
+              </a:spcAft>
+            </a:pPr>
+            <a:r>
+              <a:rPr sz="1400" b="0" i="0">
                 <a:solidFill>
                   <a:srgbClr val="FFFFFF"/>
                 </a:solidFill>
@@ -28597,11 +28480,27 @@
           <a:p>
             <a:pPr algn="l">
               <a:spcAft>
-                <a:spcPts val="0"/>
+                <a:spcPts val="1000"/>
               </a:spcAft>
             </a:pPr>
             <a:r>
-              <a:rPr sz="1500" b="0" i="0">
+              <a:rPr sz="1100" b="0" i="0">
+                <a:solidFill>
+                  <a:srgbClr val="25AEFA"/>
+                </a:solidFill>
+                <a:latin typeface="Roboto"/>
+              </a:rPr>
+              <a:t>github.com/VirtualArkansasOrg/zest-creator</a:t>
+            </a:r>
+          </a:p>
+          <a:p>
+            <a:pPr algn="l">
+              <a:spcAft>
+                <a:spcPts val="0"/>
+              </a:spcAft>
+            </a:pPr>
+            <a:r>
+              <a:rPr sz="1400" b="0" i="0">
                 <a:solidFill>
                   <a:srgbClr val="FFFFFF"/>
                 </a:solidFill>
@@ -38081,7 +37980,7 @@
           <a:p>
             <a:pPr algn="l">
               <a:spcAft>
-                <a:spcPts val="600"/>
+                <a:spcPts val="1000"/>
               </a:spcAft>
             </a:pPr>
             <a:r>
@@ -38092,6 +37991,22 @@
                 <a:latin typeface="Roboto"/>
               </a:rPr>
               <a:t>We built Zest for our own courses first, one need at a time.</a:t>
+            </a:r>
+          </a:p>
+          <a:p>
+            <a:pPr algn="l">
+              <a:spcAft>
+                <a:spcPts val="1000"/>
+              </a:spcAft>
+            </a:pPr>
+            <a:r>
+              <a:rPr sz="1200" b="0" i="1">
+                <a:solidFill>
+                  <a:srgbClr val="605F5E"/>
+                </a:solidFill>
+                <a:latin typeface="Roboto"/>
+              </a:rPr>
+              <a:t>Along the way we tested it with PhET-style science simulations.</a:t>
             </a:r>
           </a:p>
         </p:txBody>

</xml_diff>